<commit_message>
Pitch deck: clearer pricing line, speaker notes on every slide
</commit_message>
<xml_diff>
--- a/docs/pitch/Ghostkeys-pitch.pptx
+++ b/docs/pitch/Ghostkeys-pitch.pptx
@@ -112,6 +112,916 @@
     </a:lvl9pPr>
   </p:defaultTextStyle>
 </p:presentation>
+</file>
+
+<file path=ppt/notesMasters/notesMaster1.xml><?xml version="1.0" encoding="utf-8"?>
+<p:notesMaster xmlns:a="http://schemas.openxmlformats.org/drawingml/2006/main" xmlns:p="http://schemas.openxmlformats.org/presentationml/2006/main" xmlns:r="http://schemas.openxmlformats.org/officeDocument/2006/relationships">
+  <p:cSld>
+    <p:bg>
+      <p:bgRef idx="1001">
+        <a:schemeClr val="bg1"/>
+      </p:bgRef>
+    </p:bg>
+    <p:spTree>
+      <p:nvGrpSpPr>
+        <p:cNvPr id="1" name=""/>
+        <p:cNvGrpSpPr/>
+        <p:nvPr/>
+      </p:nvGrpSpPr>
+      <p:grpSpPr>
+        <a:xfrm>
+          <a:off x="0" y="0"/>
+          <a:ext cx="0" cy="0"/>
+          <a:chOff x="0" y="0"/>
+          <a:chExt cx="0" cy="0"/>
+        </a:xfrm>
+      </p:grpSpPr>
+      <p:sp>
+        <p:nvSpPr>
+          <p:cNvPr id="2" name="Header Placeholder 1"/>
+          <p:cNvSpPr>
+            <a:spLocks noGrp="1"/>
+          </p:cNvSpPr>
+          <p:nvPr>
+            <p:ph type="hdr" sz="quarter"/>
+          </p:nvPr>
+        </p:nvSpPr>
+        <p:spPr>
+          <a:xfrm>
+            <a:off x="0" y="0"/>
+            <a:ext cx="2971800" cy="457200"/>
+          </a:xfrm>
+          <a:prstGeom prst="rect">
+            <a:avLst/>
+          </a:prstGeom>
+        </p:spPr>
+        <p:txBody>
+          <a:bodyPr vert="horz" lIns="91440" tIns="45720" rIns="91440" bIns="45720" rtlCol="0"/>
+          <a:lstStyle>
+            <a:lvl1pPr algn="l">
+              <a:defRPr sz="1200"/>
+            </a:lvl1pPr>
+          </a:lstStyle>
+          <a:p>
+            <a:endParaRPr lang="en-US"/>
+          </a:p>
+        </p:txBody>
+      </p:sp>
+      <p:sp>
+        <p:nvSpPr>
+          <p:cNvPr id="3" name="Date Placeholder 2"/>
+          <p:cNvSpPr>
+            <a:spLocks noGrp="1"/>
+          </p:cNvSpPr>
+          <p:nvPr>
+            <p:ph type="dt" idx="1"/>
+          </p:nvPr>
+        </p:nvSpPr>
+        <p:spPr>
+          <a:xfrm>
+            <a:off x="3884613" y="0"/>
+            <a:ext cx="2971800" cy="457200"/>
+          </a:xfrm>
+          <a:prstGeom prst="rect">
+            <a:avLst/>
+          </a:prstGeom>
+        </p:spPr>
+        <p:txBody>
+          <a:bodyPr vert="horz" lIns="91440" tIns="45720" rIns="91440" bIns="45720" rtlCol="0"/>
+          <a:lstStyle>
+            <a:lvl1pPr algn="r">
+              <a:defRPr sz="1200"/>
+            </a:lvl1pPr>
+          </a:lstStyle>
+          <a:p>
+            <a:fld id="{0F89C1C7-3DCD-1040-A9CF-14679D8B5DDD}" type="datetimeFigureOut">
+              <a:rPr lang="en-US" smtClean="0"/>
+              <a:t>10/17/16</a:t>
+            </a:fld>
+            <a:endParaRPr lang="en-US"/>
+          </a:p>
+        </p:txBody>
+      </p:sp>
+      <p:sp>
+        <p:nvSpPr>
+          <p:cNvPr id="4" name="Slide Image Placeholder 3"/>
+          <p:cNvSpPr>
+            <a:spLocks noGrp="1" noRot="1" noChangeAspect="1"/>
+          </p:cNvSpPr>
+          <p:nvPr>
+            <p:ph type="sldImg" idx="2"/>
+          </p:nvPr>
+        </p:nvSpPr>
+        <p:spPr>
+          <a:xfrm>
+            <a:off x="1143000" y="685800"/>
+            <a:ext cx="4572000" cy="3429000"/>
+          </a:xfrm>
+          <a:prstGeom prst="rect">
+            <a:avLst/>
+          </a:prstGeom>
+          <a:noFill/>
+          <a:ln w="12700">
+            <a:solidFill>
+              <a:prstClr val="black"/>
+            </a:solidFill>
+          </a:ln>
+        </p:spPr>
+        <p:txBody>
+          <a:bodyPr vert="horz" lIns="91440" tIns="45720" rIns="91440" bIns="45720" rtlCol="0" anchor="ctr"/>
+          <a:lstStyle/>
+          <a:p>
+            <a:endParaRPr lang="en-US"/>
+          </a:p>
+        </p:txBody>
+      </p:sp>
+      <p:sp>
+        <p:nvSpPr>
+          <p:cNvPr id="5" name="Notes Placeholder 4"/>
+          <p:cNvSpPr>
+            <a:spLocks noGrp="1"/>
+          </p:cNvSpPr>
+          <p:nvPr>
+            <p:ph type="body" sz="quarter" idx="3"/>
+          </p:nvPr>
+        </p:nvSpPr>
+        <p:spPr>
+          <a:xfrm>
+            <a:off x="685800" y="4343400"/>
+            <a:ext cx="5486400" cy="4114800"/>
+          </a:xfrm>
+          <a:prstGeom prst="rect">
+            <a:avLst/>
+          </a:prstGeom>
+        </p:spPr>
+        <p:txBody>
+          <a:bodyPr vert="horz" lIns="91440" tIns="45720" rIns="91440" bIns="45720" rtlCol="0"/>
+          <a:lstStyle/>
+          <a:p>
+            <a:pPr lvl="0"/>
+            <a:r>
+              <a:rPr lang="en-US" smtClean="0"/>
+              <a:t>Click to edit Master text styles</a:t>
+            </a:r>
+          </a:p>
+          <a:p>
+            <a:pPr lvl="1"/>
+            <a:r>
+              <a:rPr lang="en-US" smtClean="0"/>
+              <a:t>Second level</a:t>
+            </a:r>
+          </a:p>
+          <a:p>
+            <a:pPr lvl="2"/>
+            <a:r>
+              <a:rPr lang="en-US" smtClean="0"/>
+              <a:t>Third level</a:t>
+            </a:r>
+          </a:p>
+          <a:p>
+            <a:pPr lvl="3"/>
+            <a:r>
+              <a:rPr lang="en-US" smtClean="0"/>
+              <a:t>Fourth level</a:t>
+            </a:r>
+          </a:p>
+          <a:p>
+            <a:pPr lvl="4"/>
+            <a:r>
+              <a:rPr lang="en-US" smtClean="0"/>
+              <a:t>Fifth level</a:t>
+            </a:r>
+            <a:endParaRPr lang="en-US"/>
+          </a:p>
+        </p:txBody>
+      </p:sp>
+      <p:sp>
+        <p:nvSpPr>
+          <p:cNvPr id="6" name="Footer Placeholder 5"/>
+          <p:cNvSpPr>
+            <a:spLocks noGrp="1"/>
+          </p:cNvSpPr>
+          <p:nvPr>
+            <p:ph type="ftr" sz="quarter" idx="4"/>
+          </p:nvPr>
+        </p:nvSpPr>
+        <p:spPr>
+          <a:xfrm>
+            <a:off x="0" y="8685213"/>
+            <a:ext cx="2971800" cy="457200"/>
+          </a:xfrm>
+          <a:prstGeom prst="rect">
+            <a:avLst/>
+          </a:prstGeom>
+        </p:spPr>
+        <p:txBody>
+          <a:bodyPr vert="horz" lIns="91440" tIns="45720" rIns="91440" bIns="45720" rtlCol="0" anchor="b"/>
+          <a:lstStyle>
+            <a:lvl1pPr algn="l">
+              <a:defRPr sz="1200"/>
+            </a:lvl1pPr>
+          </a:lstStyle>
+          <a:p>
+            <a:endParaRPr lang="en-US"/>
+          </a:p>
+        </p:txBody>
+      </p:sp>
+      <p:sp>
+        <p:nvSpPr>
+          <p:cNvPr id="7" name="Slide Number Placeholder 6"/>
+          <p:cNvSpPr>
+            <a:spLocks noGrp="1"/>
+          </p:cNvSpPr>
+          <p:nvPr>
+            <p:ph type="sldNum" sz="quarter" idx="5"/>
+          </p:nvPr>
+        </p:nvSpPr>
+        <p:spPr>
+          <a:xfrm>
+            <a:off x="3884613" y="8685213"/>
+            <a:ext cx="2971800" cy="457200"/>
+          </a:xfrm>
+          <a:prstGeom prst="rect">
+            <a:avLst/>
+          </a:prstGeom>
+        </p:spPr>
+        <p:txBody>
+          <a:bodyPr vert="horz" lIns="91440" tIns="45720" rIns="91440" bIns="45720" rtlCol="0" anchor="b"/>
+          <a:lstStyle>
+            <a:lvl1pPr algn="r">
+              <a:defRPr sz="1200"/>
+            </a:lvl1pPr>
+          </a:lstStyle>
+          <a:p>
+            <a:fld id="{BB5E49A5-4136-284D-997B-48E1D791AD67}" type="slidenum">
+              <a:rPr lang="en-US" smtClean="0"/>
+              <a:t>‹#›</a:t>
+            </a:fld>
+            <a:endParaRPr lang="en-US"/>
+          </a:p>
+        </p:txBody>
+      </p:sp>
+    </p:spTree>
+    <p:extLst>
+      <p:ext uri="{BB962C8B-B14F-4D97-AF65-F5344CB8AC3E}">
+        <p14:creationId xmlns:p14="http://schemas.microsoft.com/office/powerpoint/2010/main" val="2623252185"/>
+      </p:ext>
+    </p:extLst>
+  </p:cSld>
+  <p:clrMap bg1="lt1" tx1="dk1" bg2="lt2" tx2="dk2" accent1="accent1" accent2="accent2" accent3="accent3" accent4="accent4" accent5="accent5" accent6="accent6" hlink="hlink" folHlink="folHlink"/>
+  <p:notesStyle>
+    <a:lvl1pPr marL="0" algn="l" defTabSz="457200" rtl="0" eaLnBrk="1" latinLnBrk="0" hangingPunct="1">
+      <a:defRPr sz="1200" kern="1200">
+        <a:solidFill>
+          <a:schemeClr val="tx1"/>
+        </a:solidFill>
+        <a:latin typeface="+mn-lt"/>
+        <a:ea typeface="+mn-ea"/>
+        <a:cs typeface="+mn-cs"/>
+      </a:defRPr>
+    </a:lvl1pPr>
+    <a:lvl2pPr marL="457200" algn="l" defTabSz="457200" rtl="0" eaLnBrk="1" latinLnBrk="0" hangingPunct="1">
+      <a:defRPr sz="1200" kern="1200">
+        <a:solidFill>
+          <a:schemeClr val="tx1"/>
+        </a:solidFill>
+        <a:latin typeface="+mn-lt"/>
+        <a:ea typeface="+mn-ea"/>
+        <a:cs typeface="+mn-cs"/>
+      </a:defRPr>
+    </a:lvl2pPr>
+    <a:lvl3pPr marL="914400" algn="l" defTabSz="457200" rtl="0" eaLnBrk="1" latinLnBrk="0" hangingPunct="1">
+      <a:defRPr sz="1200" kern="1200">
+        <a:solidFill>
+          <a:schemeClr val="tx1"/>
+        </a:solidFill>
+        <a:latin typeface="+mn-lt"/>
+        <a:ea typeface="+mn-ea"/>
+        <a:cs typeface="+mn-cs"/>
+      </a:defRPr>
+    </a:lvl3pPr>
+    <a:lvl4pPr marL="1371600" algn="l" defTabSz="457200" rtl="0" eaLnBrk="1" latinLnBrk="0" hangingPunct="1">
+      <a:defRPr sz="1200" kern="1200">
+        <a:solidFill>
+          <a:schemeClr val="tx1"/>
+        </a:solidFill>
+        <a:latin typeface="+mn-lt"/>
+        <a:ea typeface="+mn-ea"/>
+        <a:cs typeface="+mn-cs"/>
+      </a:defRPr>
+    </a:lvl4pPr>
+    <a:lvl5pPr marL="1828800" algn="l" defTabSz="457200" rtl="0" eaLnBrk="1" latinLnBrk="0" hangingPunct="1">
+      <a:defRPr sz="1200" kern="1200">
+        <a:solidFill>
+          <a:schemeClr val="tx1"/>
+        </a:solidFill>
+        <a:latin typeface="+mn-lt"/>
+        <a:ea typeface="+mn-ea"/>
+        <a:cs typeface="+mn-cs"/>
+      </a:defRPr>
+    </a:lvl5pPr>
+    <a:lvl6pPr marL="2286000" algn="l" defTabSz="457200" rtl="0" eaLnBrk="1" latinLnBrk="0" hangingPunct="1">
+      <a:defRPr sz="1200" kern="1200">
+        <a:solidFill>
+          <a:schemeClr val="tx1"/>
+        </a:solidFill>
+        <a:latin typeface="+mn-lt"/>
+        <a:ea typeface="+mn-ea"/>
+        <a:cs typeface="+mn-cs"/>
+      </a:defRPr>
+    </a:lvl6pPr>
+    <a:lvl7pPr marL="2743200" algn="l" defTabSz="457200" rtl="0" eaLnBrk="1" latinLnBrk="0" hangingPunct="1">
+      <a:defRPr sz="1200" kern="1200">
+        <a:solidFill>
+          <a:schemeClr val="tx1"/>
+        </a:solidFill>
+        <a:latin typeface="+mn-lt"/>
+        <a:ea typeface="+mn-ea"/>
+        <a:cs typeface="+mn-cs"/>
+      </a:defRPr>
+    </a:lvl7pPr>
+    <a:lvl8pPr marL="3200400" algn="l" defTabSz="457200" rtl="0" eaLnBrk="1" latinLnBrk="0" hangingPunct="1">
+      <a:defRPr sz="1200" kern="1200">
+        <a:solidFill>
+          <a:schemeClr val="tx1"/>
+        </a:solidFill>
+        <a:latin typeface="+mn-lt"/>
+        <a:ea typeface="+mn-ea"/>
+        <a:cs typeface="+mn-cs"/>
+      </a:defRPr>
+    </a:lvl8pPr>
+    <a:lvl9pPr marL="3657600" algn="l" defTabSz="457200" rtl="0" eaLnBrk="1" latinLnBrk="0" hangingPunct="1">
+      <a:defRPr sz="1200" kern="1200">
+        <a:solidFill>
+          <a:schemeClr val="tx1"/>
+        </a:solidFill>
+        <a:latin typeface="+mn-lt"/>
+        <a:ea typeface="+mn-ea"/>
+        <a:cs typeface="+mn-cs"/>
+      </a:defRPr>
+    </a:lvl9pPr>
+  </p:notesStyle>
+</p:notesMaster>
+</file>
+
+<file path=ppt/notesSlides/notesSlide1.xml><?xml version="1.0" encoding="utf-8"?>
+<p:notes xmlns:a="http://schemas.openxmlformats.org/drawingml/2006/main" xmlns:p="http://schemas.openxmlformats.org/presentationml/2006/main" xmlns:r="http://schemas.openxmlformats.org/officeDocument/2006/relationships">
+  <p:cSld>
+    <p:spTree>
+      <p:nvGrpSpPr>
+        <p:cNvPr id="1" name=""/>
+        <p:cNvGrpSpPr/>
+        <p:nvPr/>
+      </p:nvGrpSpPr>
+      <p:grpSpPr>
+        <a:xfrm>
+          <a:off x="0" y="0"/>
+          <a:ext cx="0" cy="0"/>
+          <a:chOff x="0" y="0"/>
+          <a:chExt cx="0" cy="0"/>
+        </a:xfrm>
+      </p:grpSpPr>
+      <p:sp>
+        <p:nvSpPr>
+          <p:cNvPr id="2" name="Slide Image Placeholder 1"/>
+          <p:cNvSpPr>
+            <a:spLocks noGrp="1"/>
+          </p:cNvSpPr>
+          <p:nvPr>
+            <p:ph type="sldImg" idx="2"/>
+          </p:nvPr>
+        </p:nvSpPr>
+        <p:spPr/>
+      </p:sp>
+      <p:sp>
+        <p:nvSpPr>
+          <p:cNvPr id="3" name="Notes Placeholder 2"/>
+          <p:cNvSpPr>
+            <a:spLocks noGrp="1"/>
+          </p:cNvSpPr>
+          <p:nvPr>
+            <p:ph type="body" idx="3" sz="quarter"/>
+          </p:nvPr>
+        </p:nvSpPr>
+        <p:spPr/>
+        <p:txBody>
+          <a:bodyPr/>
+          <a:lstStyle/>
+          <a:p>
+            <a:r>
+              <a:t>This is Ghostkeys. It turns the blank parts of your MacBook, the palm rests, the speaker grilles and the strip above the keys, into buttons. No new hardware, nothing to plug in.</a:t>
+            </a:r>
+          </a:p>
+        </p:txBody>
+      </p:sp>
+      <p:sp>
+        <p:nvSpPr>
+          <p:cNvPr id="4" name="Slide Number Placeholder 3"/>
+          <p:cNvSpPr>
+            <a:spLocks noGrp="1"/>
+          </p:cNvSpPr>
+          <p:nvPr>
+            <p:ph type="sldNum" idx="5" sz="quarter"/>
+          </p:nvPr>
+        </p:nvSpPr>
+        <p:spPr/>
+      </p:sp>
+    </p:spTree>
+  </p:cSld>
+  <p:clrMapOvr>
+    <a:masterClrMapping/>
+  </p:clrMapOvr>
+</p:notes>
+</file>
+
+<file path=ppt/notesSlides/notesSlide2.xml><?xml version="1.0" encoding="utf-8"?>
+<p:notes xmlns:a="http://schemas.openxmlformats.org/drawingml/2006/main" xmlns:p="http://schemas.openxmlformats.org/presentationml/2006/main" xmlns:r="http://schemas.openxmlformats.org/officeDocument/2006/relationships">
+  <p:cSld>
+    <p:spTree>
+      <p:nvGrpSpPr>
+        <p:cNvPr id="1" name=""/>
+        <p:cNvGrpSpPr/>
+        <p:nvPr/>
+      </p:nvGrpSpPr>
+      <p:grpSpPr>
+        <a:xfrm>
+          <a:off x="0" y="0"/>
+          <a:ext cx="0" cy="0"/>
+          <a:chOff x="0" y="0"/>
+          <a:chExt cx="0" cy="0"/>
+        </a:xfrm>
+      </p:grpSpPr>
+      <p:sp>
+        <p:nvSpPr>
+          <p:cNvPr id="2" name="Slide Image Placeholder 1"/>
+          <p:cNvSpPr>
+            <a:spLocks noGrp="1"/>
+          </p:cNvSpPr>
+          <p:nvPr>
+            <p:ph type="sldImg" idx="2"/>
+          </p:nvPr>
+        </p:nvSpPr>
+        <p:spPr/>
+      </p:sp>
+      <p:sp>
+        <p:nvSpPr>
+          <p:cNvPr id="3" name="Notes Placeholder 2"/>
+          <p:cNvSpPr>
+            <a:spLocks noGrp="1"/>
+          </p:cNvSpPr>
+          <p:nvPr>
+            <p:ph type="body" idx="3" sz="quarter"/>
+          </p:nvPr>
+        </p:nvSpPr>
+        <p:spPr/>
+        <p:txBody>
+          <a:bodyPr/>
+          <a:lstStyle/>
+          <a:p>
+            <a:r>
+              <a:t>Look at a MacBook: a lot of the top is dead space. With Ghostkeys you tap it. Tap the top strip to jump back to your last app, double tap the right grille for a screenshot, tap the left palm rest to mute a call. You choose what each spot does.</a:t>
+            </a:r>
+          </a:p>
+        </p:txBody>
+      </p:sp>
+      <p:sp>
+        <p:nvSpPr>
+          <p:cNvPr id="4" name="Slide Number Placeholder 3"/>
+          <p:cNvSpPr>
+            <a:spLocks noGrp="1"/>
+          </p:cNvSpPr>
+          <p:nvPr>
+            <p:ph type="sldNum" idx="5" sz="quarter"/>
+          </p:nvPr>
+        </p:nvSpPr>
+        <p:spPr/>
+      </p:sp>
+    </p:spTree>
+  </p:cSld>
+  <p:clrMapOvr>
+    <a:masterClrMapping/>
+  </p:clrMapOvr>
+</p:notes>
+</file>
+
+<file path=ppt/notesSlides/notesSlide3.xml><?xml version="1.0" encoding="utf-8"?>
+<p:notes xmlns:a="http://schemas.openxmlformats.org/drawingml/2006/main" xmlns:p="http://schemas.openxmlformats.org/presentationml/2006/main" xmlns:r="http://schemas.openxmlformats.org/officeDocument/2006/relationships">
+  <p:cSld>
+    <p:spTree>
+      <p:nvGrpSpPr>
+        <p:cNvPr id="1" name=""/>
+        <p:cNvGrpSpPr/>
+        <p:nvPr/>
+      </p:nvGrpSpPr>
+      <p:grpSpPr>
+        <a:xfrm>
+          <a:off x="0" y="0"/>
+          <a:ext cx="0" cy="0"/>
+          <a:chOff x="0" y="0"/>
+          <a:chExt cx="0" cy="0"/>
+        </a:xfrm>
+      </p:grpSpPr>
+      <p:sp>
+        <p:nvSpPr>
+          <p:cNvPr id="2" name="Slide Image Placeholder 1"/>
+          <p:cNvSpPr>
+            <a:spLocks noGrp="1"/>
+          </p:cNvSpPr>
+          <p:nvPr>
+            <p:ph type="sldImg" idx="2"/>
+          </p:nvPr>
+        </p:nvSpPr>
+        <p:spPr/>
+      </p:sp>
+      <p:sp>
+        <p:nvSpPr>
+          <p:cNvPr id="3" name="Notes Placeholder 2"/>
+          <p:cNvSpPr>
+            <a:spLocks noGrp="1"/>
+          </p:cNvSpPr>
+          <p:nvPr>
+            <p:ph type="body" idx="3" sz="quarter"/>
+          </p:nvPr>
+        </p:nvSpPr>
+        <p:spPr/>
+        <p:txBody>
+          <a:bodyPr/>
+          <a:lstStyle/>
+          <a:p>
+            <a:r>
+              <a:t>The hard part: every Apple silicon MacBook has a motion sensor inside that reads 800 times a second, and a tap barely shows up on it. Typing looks almost the same, as you can see. So every bump goes through four checks: did something hit, were you typing or on the trackpad, which spot was it, and are we sure. If we are not sure, we do nothing. A missed tap costs a second try. A wrong action costs trust.</a:t>
+            </a:r>
+          </a:p>
+        </p:txBody>
+      </p:sp>
+      <p:sp>
+        <p:nvSpPr>
+          <p:cNvPr id="4" name="Slide Number Placeholder 3"/>
+          <p:cNvSpPr>
+            <a:spLocks noGrp="1"/>
+          </p:cNvSpPr>
+          <p:nvPr>
+            <p:ph type="sldNum" idx="5" sz="quarter"/>
+          </p:nvPr>
+        </p:nvSpPr>
+        <p:spPr/>
+      </p:sp>
+    </p:spTree>
+  </p:cSld>
+  <p:clrMapOvr>
+    <a:masterClrMapping/>
+  </p:clrMapOvr>
+</p:notes>
+</file>
+
+<file path=ppt/notesSlides/notesSlide4.xml><?xml version="1.0" encoding="utf-8"?>
+<p:notes xmlns:a="http://schemas.openxmlformats.org/drawingml/2006/main" xmlns:p="http://schemas.openxmlformats.org/presentationml/2006/main" xmlns:r="http://schemas.openxmlformats.org/officeDocument/2006/relationships">
+  <p:cSld>
+    <p:spTree>
+      <p:nvGrpSpPr>
+        <p:cNvPr id="1" name=""/>
+        <p:cNvGrpSpPr/>
+        <p:nvPr/>
+      </p:nvGrpSpPr>
+      <p:grpSpPr>
+        <a:xfrm>
+          <a:off x="0" y="0"/>
+          <a:ext cx="0" cy="0"/>
+          <a:chOff x="0" y="0"/>
+          <a:chExt cx="0" cy="0"/>
+        </a:xfrm>
+      </p:grpSpPr>
+      <p:sp>
+        <p:nvSpPr>
+          <p:cNvPr id="2" name="Slide Image Placeholder 1"/>
+          <p:cNvSpPr>
+            <a:spLocks noGrp="1"/>
+          </p:cNvSpPr>
+          <p:nvPr>
+            <p:ph type="sldImg" idx="2"/>
+          </p:nvPr>
+        </p:nvSpPr>
+        <p:spPr/>
+      </p:sp>
+      <p:sp>
+        <p:nvSpPr>
+          <p:cNvPr id="3" name="Notes Placeholder 2"/>
+          <p:cNvSpPr>
+            <a:spLocks noGrp="1"/>
+          </p:cNvSpPr>
+          <p:nvPr>
+            <p:ph type="body" idx="3" sz="quarter"/>
+          </p:nvPr>
+        </p:nvSpPr>
+        <p:spPr/>
+        <p:txBody>
+          <a:bodyPr/>
+          <a:lstStyle/>
+          <a:p>
+            <a:r>
+              <a:t>It also works without touching. The speakers play two tones too high for people to hear, and the mic listens to how your hand changes them. Raise or lower your hand to change the volume. It is early, and it needs the Mac's own speakers.</a:t>
+            </a:r>
+          </a:p>
+        </p:txBody>
+      </p:sp>
+      <p:sp>
+        <p:nvSpPr>
+          <p:cNvPr id="4" name="Slide Number Placeholder 3"/>
+          <p:cNvSpPr>
+            <a:spLocks noGrp="1"/>
+          </p:cNvSpPr>
+          <p:nvPr>
+            <p:ph type="sldNum" idx="5" sz="quarter"/>
+          </p:nvPr>
+        </p:nvSpPr>
+        <p:spPr/>
+      </p:sp>
+    </p:spTree>
+  </p:cSld>
+  <p:clrMapOvr>
+    <a:masterClrMapping/>
+  </p:clrMapOvr>
+</p:notes>
+</file>
+
+<file path=ppt/notesSlides/notesSlide5.xml><?xml version="1.0" encoding="utf-8"?>
+<p:notes xmlns:a="http://schemas.openxmlformats.org/drawingml/2006/main" xmlns:p="http://schemas.openxmlformats.org/presentationml/2006/main" xmlns:r="http://schemas.openxmlformats.org/officeDocument/2006/relationships">
+  <p:cSld>
+    <p:spTree>
+      <p:nvGrpSpPr>
+        <p:cNvPr id="1" name=""/>
+        <p:cNvGrpSpPr/>
+        <p:nvPr/>
+      </p:nvGrpSpPr>
+      <p:grpSpPr>
+        <a:xfrm>
+          <a:off x="0" y="0"/>
+          <a:ext cx="0" cy="0"/>
+          <a:chOff x="0" y="0"/>
+          <a:chExt cx="0" cy="0"/>
+        </a:xfrm>
+      </p:grpSpPr>
+      <p:sp>
+        <p:nvSpPr>
+          <p:cNvPr id="2" name="Slide Image Placeholder 1"/>
+          <p:cNvSpPr>
+            <a:spLocks noGrp="1"/>
+          </p:cNvSpPr>
+          <p:nvPr>
+            <p:ph type="sldImg" idx="2"/>
+          </p:nvPr>
+        </p:nvSpPr>
+        <p:spPr/>
+      </p:sp>
+      <p:sp>
+        <p:nvSpPr>
+          <p:cNvPr id="3" name="Notes Placeholder 2"/>
+          <p:cNvSpPr>
+            <a:spLocks noGrp="1"/>
+          </p:cNvSpPr>
+          <p:nvPr>
+            <p:ph type="body" idx="3" sz="quarter"/>
+          </p:nvPr>
+        </p:nvSpPr>
+        <p:spPr/>
+        <p:txBody>
+          <a:bodyPr/>
+          <a:lstStyle/>
+          <a:p>
+            <a:r>
+              <a:t>If you have a camera, you can pinch in the air in front of the screen, like turning a dial. It is optional and off by default, and the video never leaves the Mac.</a:t>
+            </a:r>
+          </a:p>
+        </p:txBody>
+      </p:sp>
+      <p:sp>
+        <p:nvSpPr>
+          <p:cNvPr id="4" name="Slide Number Placeholder 3"/>
+          <p:cNvSpPr>
+            <a:spLocks noGrp="1"/>
+          </p:cNvSpPr>
+          <p:nvPr>
+            <p:ph type="sldNum" idx="5" sz="quarter"/>
+          </p:nvPr>
+        </p:nvSpPr>
+        <p:spPr/>
+      </p:sp>
+    </p:spTree>
+  </p:cSld>
+  <p:clrMapOvr>
+    <a:masterClrMapping/>
+  </p:clrMapOvr>
+</p:notes>
+</file>
+
+<file path=ppt/notesSlides/notesSlide6.xml><?xml version="1.0" encoding="utf-8"?>
+<p:notes xmlns:a="http://schemas.openxmlformats.org/drawingml/2006/main" xmlns:p="http://schemas.openxmlformats.org/presentationml/2006/main" xmlns:r="http://schemas.openxmlformats.org/officeDocument/2006/relationships">
+  <p:cSld>
+    <p:spTree>
+      <p:nvGrpSpPr>
+        <p:cNvPr id="1" name=""/>
+        <p:cNvGrpSpPr/>
+        <p:nvPr/>
+      </p:nvGrpSpPr>
+      <p:grpSpPr>
+        <a:xfrm>
+          <a:off x="0" y="0"/>
+          <a:ext cx="0" cy="0"/>
+          <a:chOff x="0" y="0"/>
+          <a:chExt cx="0" cy="0"/>
+        </a:xfrm>
+      </p:grpSpPr>
+      <p:sp>
+        <p:nvSpPr>
+          <p:cNvPr id="2" name="Slide Image Placeholder 1"/>
+          <p:cNvSpPr>
+            <a:spLocks noGrp="1"/>
+          </p:cNvSpPr>
+          <p:nvPr>
+            <p:ph type="sldImg" idx="2"/>
+          </p:nvPr>
+        </p:nvSpPr>
+        <p:spPr/>
+      </p:sp>
+      <p:sp>
+        <p:nvSpPr>
+          <p:cNvPr id="3" name="Notes Placeholder 2"/>
+          <p:cNvSpPr>
+            <a:spLocks noGrp="1"/>
+          </p:cNvSpPr>
+          <p:nvPr>
+            <p:ph type="body" idx="3" sz="quarter"/>
+          </p:nvPr>
+        </p:nvSpPr>
+        <p:spPr/>
+        <p:txBody>
+          <a:bodyPr/>
+          <a:lstStyle/>
+          <a:p>
+            <a:r>
+              <a:t>We measured it on our own recordings, and someone who did not write the code re-checked every number. Wrong taps went from 16.5 percent to 1.4. Picking up the laptop used to set off about two false taps a minute, now none. And after calibrating on your lap, it catches 84 percent of lap taps, up from zero.</a:t>
+            </a:r>
+          </a:p>
+        </p:txBody>
+      </p:sp>
+      <p:sp>
+        <p:nvSpPr>
+          <p:cNvPr id="4" name="Slide Number Placeholder 3"/>
+          <p:cNvSpPr>
+            <a:spLocks noGrp="1"/>
+          </p:cNvSpPr>
+          <p:nvPr>
+            <p:ph type="sldNum" idx="5" sz="quarter"/>
+          </p:nvPr>
+        </p:nvSpPr>
+        <p:spPr/>
+      </p:sp>
+    </p:spTree>
+  </p:cSld>
+  <p:clrMapOvr>
+    <a:masterClrMapping/>
+  </p:clrMapOvr>
+</p:notes>
+</file>
+
+<file path=ppt/notesSlides/notesSlide7.xml><?xml version="1.0" encoding="utf-8"?>
+<p:notes xmlns:a="http://schemas.openxmlformats.org/drawingml/2006/main" xmlns:p="http://schemas.openxmlformats.org/presentationml/2006/main" xmlns:r="http://schemas.openxmlformats.org/officeDocument/2006/relationships">
+  <p:cSld>
+    <p:spTree>
+      <p:nvGrpSpPr>
+        <p:cNvPr id="1" name=""/>
+        <p:cNvGrpSpPr/>
+        <p:nvPr/>
+      </p:nvGrpSpPr>
+      <p:grpSpPr>
+        <a:xfrm>
+          <a:off x="0" y="0"/>
+          <a:ext cx="0" cy="0"/>
+          <a:chOff x="0" y="0"/>
+          <a:chExt cx="0" cy="0"/>
+        </a:xfrm>
+      </p:grpSpPr>
+      <p:sp>
+        <p:nvSpPr>
+          <p:cNvPr id="2" name="Slide Image Placeholder 1"/>
+          <p:cNvSpPr>
+            <a:spLocks noGrp="1"/>
+          </p:cNvSpPr>
+          <p:nvPr>
+            <p:ph type="sldImg" idx="2"/>
+          </p:nvPr>
+        </p:nvSpPr>
+        <p:spPr/>
+      </p:sp>
+      <p:sp>
+        <p:nvSpPr>
+          <p:cNvPr id="3" name="Notes Placeholder 2"/>
+          <p:cNvSpPr>
+            <a:spLocks noGrp="1"/>
+          </p:cNvSpPr>
+          <p:nvPr>
+            <p:ph type="body" idx="3" sz="quarter"/>
+          </p:nvPr>
+        </p:nvSpPr>
+        <p:spPr/>
+        <p:txBody>
+          <a:bodyPr/>
+          <a:lstStyle/>
+          <a:p>
+            <a:r>
+              <a:t>The business is simple. Free gets you two palm buttons. Pro is 29 dollars once for everything. Teams is 49 dollars per seat per year. There is nothing to buy, because every Apple silicon MacBook already has the sensor. It is free while we are in beta.</a:t>
+            </a:r>
+          </a:p>
+        </p:txBody>
+      </p:sp>
+      <p:sp>
+        <p:nvSpPr>
+          <p:cNvPr id="4" name="Slide Number Placeholder 3"/>
+          <p:cNvSpPr>
+            <a:spLocks noGrp="1"/>
+          </p:cNvSpPr>
+          <p:nvPr>
+            <p:ph type="sldNum" idx="5" sz="quarter"/>
+          </p:nvPr>
+        </p:nvSpPr>
+        <p:spPr/>
+      </p:sp>
+    </p:spTree>
+  </p:cSld>
+  <p:clrMapOvr>
+    <a:masterClrMapping/>
+  </p:clrMapOvr>
+</p:notes>
+</file>
+
+<file path=ppt/notesSlides/notesSlide8.xml><?xml version="1.0" encoding="utf-8"?>
+<p:notes xmlns:a="http://schemas.openxmlformats.org/drawingml/2006/main" xmlns:p="http://schemas.openxmlformats.org/presentationml/2006/main" xmlns:r="http://schemas.openxmlformats.org/officeDocument/2006/relationships">
+  <p:cSld>
+    <p:spTree>
+      <p:nvGrpSpPr>
+        <p:cNvPr id="1" name=""/>
+        <p:cNvGrpSpPr/>
+        <p:nvPr/>
+      </p:nvGrpSpPr>
+      <p:grpSpPr>
+        <a:xfrm>
+          <a:off x="0" y="0"/>
+          <a:ext cx="0" cy="0"/>
+          <a:chOff x="0" y="0"/>
+          <a:chExt cx="0" cy="0"/>
+        </a:xfrm>
+      </p:grpSpPr>
+      <p:sp>
+        <p:nvSpPr>
+          <p:cNvPr id="2" name="Slide Image Placeholder 1"/>
+          <p:cNvSpPr>
+            <a:spLocks noGrp="1"/>
+          </p:cNvSpPr>
+          <p:nvPr>
+            <p:ph type="sldImg" idx="2"/>
+          </p:nvPr>
+        </p:nvSpPr>
+        <p:spPr/>
+      </p:sp>
+      <p:sp>
+        <p:nvSpPr>
+          <p:cNvPr id="3" name="Notes Placeholder 2"/>
+          <p:cNvSpPr>
+            <a:spLocks noGrp="1"/>
+          </p:cNvSpPr>
+          <p:nvPr>
+            <p:ph type="body" idx="3" sz="quarter"/>
+          </p:nvPr>
+        </p:nvSpPr>
+        <p:spPr/>
+        <p:txBody>
+          <a:bodyPr/>
+          <a:lstStyle/>
+          <a:p>
+            <a:r>
+              <a:t>It is live now. Try it on the laptop in front of you. Thank you.</a:t>
+            </a:r>
+          </a:p>
+        </p:txBody>
+      </p:sp>
+      <p:sp>
+        <p:nvSpPr>
+          <p:cNvPr id="4" name="Slide Number Placeholder 3"/>
+          <p:cNvSpPr>
+            <a:spLocks noGrp="1"/>
+          </p:cNvSpPr>
+          <p:nvPr>
+            <p:ph type="sldNum" idx="5" sz="quarter"/>
+          </p:nvPr>
+        </p:nvSpPr>
+        <p:spPr/>
+      </p:sp>
+    </p:spTree>
+  </p:cSld>
+  <p:clrMapOvr>
+    <a:masterClrMapping/>
+  </p:clrMapOvr>
+</p:notes>
 </file>
 
 <file path=ppt/slideLayouts/slideLayout1.xml><?xml version="1.0" encoding="utf-8"?>
@@ -14952,7 +15862,7 @@
                 </a:solidFill>
                 <a:latin typeface="Switzer Extralight"/>
               </a:rPr>
-              <a:t>Nothing to buy. Pay once.</a:t>
+              <a:t>Free to try. Pay once to unlock everything.</a:t>
             </a:r>
           </a:p>
         </p:txBody>
@@ -15995,4 +16905,324 @@
   </a:objectDefaults>
   <a:extraClrSchemeLst/>
 </a:theme>
+</file>
+
+<file path=ppt/theme/theme2.xml><?xml version="1.0" encoding="utf-8"?>
+<a:theme xmlns:a="http://schemas.openxmlformats.org/drawingml/2006/main" name="Office Theme">
+  <a:themeElements>
+    <a:clrScheme name="Office">
+      <a:dk1>
+        <a:sysClr val="windowText" lastClr="000000"/>
+      </a:dk1>
+      <a:lt1>
+        <a:sysClr val="window" lastClr="FFFFFF"/>
+      </a:lt1>
+      <a:dk2>
+        <a:srgbClr val="1F497D"/>
+      </a:dk2>
+      <a:lt2>
+        <a:srgbClr val="EEECE1"/>
+      </a:lt2>
+      <a:accent1>
+        <a:srgbClr val="4F81BD"/>
+      </a:accent1>
+      <a:accent2>
+        <a:srgbClr val="C0504D"/>
+      </a:accent2>
+      <a:accent3>
+        <a:srgbClr val="9BBB59"/>
+      </a:accent3>
+      <a:accent4>
+        <a:srgbClr val="8064A2"/>
+      </a:accent4>
+      <a:accent5>
+        <a:srgbClr val="4BACC6"/>
+      </a:accent5>
+      <a:accent6>
+        <a:srgbClr val="F79646"/>
+      </a:accent6>
+      <a:hlink>
+        <a:srgbClr val="0000FF"/>
+      </a:hlink>
+      <a:folHlink>
+        <a:srgbClr val="800080"/>
+      </a:folHlink>
+    </a:clrScheme>
+    <a:fontScheme name="Office">
+      <a:majorFont>
+        <a:latin typeface="Calibri"/>
+        <a:ea typeface=""/>
+        <a:cs typeface=""/>
+        <a:font script="Jpan" typeface="ＭＳ Ｐゴシック"/>
+        <a:font script="Hang" typeface="맑은 고딕"/>
+        <a:font script="Hans" typeface="宋体"/>
+        <a:font script="Hant" typeface="新細明體"/>
+        <a:font script="Arab" typeface="Times New Roman"/>
+        <a:font script="Hebr" typeface="Times New Roman"/>
+        <a:font script="Thai" typeface="Angsana New"/>
+        <a:font script="Ethi" typeface="Nyala"/>
+        <a:font script="Beng" typeface="Vrinda"/>
+        <a:font script="Gujr" typeface="Shruti"/>
+        <a:font script="Khmr" typeface="MoolBoran"/>
+        <a:font script="Knda" typeface="Tunga"/>
+        <a:font script="Guru" typeface="Raavi"/>
+        <a:font script="Cans" typeface="Euphemia"/>
+        <a:font script="Cher" typeface="Plantagenet Cherokee"/>
+        <a:font script="Yiii" typeface="Microsoft Yi Baiti"/>
+        <a:font script="Tibt" typeface="Microsoft Himalaya"/>
+        <a:font script="Thaa" typeface="MV Boli"/>
+        <a:font script="Deva" typeface="Mangal"/>
+        <a:font script="Telu" typeface="Gautami"/>
+        <a:font script="Taml" typeface="Latha"/>
+        <a:font script="Syrc" typeface="Estrangelo Edessa"/>
+        <a:font script="Orya" typeface="Kalinga"/>
+        <a:font script="Mlym" typeface="Kartika"/>
+        <a:font script="Laoo" typeface="DokChampa"/>
+        <a:font script="Sinh" typeface="Iskoola Pota"/>
+        <a:font script="Mong" typeface="Mongolian Baiti"/>
+        <a:font script="Viet" typeface="Times New Roman"/>
+        <a:font script="Uigh" typeface="Microsoft Uighur"/>
+        <a:font script="Geor" typeface="Sylfaen"/>
+      </a:majorFont>
+      <a:minorFont>
+        <a:latin typeface="Calibri"/>
+        <a:ea typeface=""/>
+        <a:cs typeface=""/>
+        <a:font script="Jpan" typeface="ＭＳ Ｐゴシック"/>
+        <a:font script="Hang" typeface="맑은 고딕"/>
+        <a:font script="Hans" typeface="宋体"/>
+        <a:font script="Hant" typeface="新細明體"/>
+        <a:font script="Arab" typeface="Arial"/>
+        <a:font script="Hebr" typeface="Arial"/>
+        <a:font script="Thai" typeface="Cordia New"/>
+        <a:font script="Ethi" typeface="Nyala"/>
+        <a:font script="Beng" typeface="Vrinda"/>
+        <a:font script="Gujr" typeface="Shruti"/>
+        <a:font script="Khmr" typeface="DaunPenh"/>
+        <a:font script="Knda" typeface="Tunga"/>
+        <a:font script="Guru" typeface="Raavi"/>
+        <a:font script="Cans" typeface="Euphemia"/>
+        <a:font script="Cher" typeface="Plantagenet Cherokee"/>
+        <a:font script="Yiii" typeface="Microsoft Yi Baiti"/>
+        <a:font script="Tibt" typeface="Microsoft Himalaya"/>
+        <a:font script="Thaa" typeface="MV Boli"/>
+        <a:font script="Deva" typeface="Mangal"/>
+        <a:font script="Telu" typeface="Gautami"/>
+        <a:font script="Taml" typeface="Latha"/>
+        <a:font script="Syrc" typeface="Estrangelo Edessa"/>
+        <a:font script="Orya" typeface="Kalinga"/>
+        <a:font script="Mlym" typeface="Kartika"/>
+        <a:font script="Laoo" typeface="DokChampa"/>
+        <a:font script="Sinh" typeface="Iskoola Pota"/>
+        <a:font script="Mong" typeface="Mongolian Baiti"/>
+        <a:font script="Viet" typeface="Arial"/>
+        <a:font script="Uigh" typeface="Microsoft Uighur"/>
+        <a:font script="Geor" typeface="Sylfaen"/>
+      </a:minorFont>
+    </a:fontScheme>
+    <a:fmtScheme name="Office">
+      <a:fillStyleLst>
+        <a:solidFill>
+          <a:schemeClr val="phClr"/>
+        </a:solidFill>
+        <a:gradFill rotWithShape="1">
+          <a:gsLst>
+            <a:gs pos="0">
+              <a:schemeClr val="phClr">
+                <a:tint val="50000"/>
+                <a:satMod val="300000"/>
+              </a:schemeClr>
+            </a:gs>
+            <a:gs pos="35000">
+              <a:schemeClr val="phClr">
+                <a:tint val="37000"/>
+                <a:satMod val="300000"/>
+              </a:schemeClr>
+            </a:gs>
+            <a:gs pos="100000">
+              <a:schemeClr val="phClr">
+                <a:tint val="15000"/>
+                <a:satMod val="350000"/>
+              </a:schemeClr>
+            </a:gs>
+          </a:gsLst>
+          <a:lin ang="16200000" scaled="1"/>
+        </a:gradFill>
+        <a:gradFill rotWithShape="1">
+          <a:gsLst>
+            <a:gs pos="0">
+              <a:schemeClr val="phClr">
+                <a:tint val="100000"/>
+                <a:shade val="100000"/>
+                <a:satMod val="130000"/>
+              </a:schemeClr>
+            </a:gs>
+            <a:gs pos="100000">
+              <a:schemeClr val="phClr">
+                <a:tint val="50000"/>
+                <a:shade val="100000"/>
+                <a:satMod val="350000"/>
+              </a:schemeClr>
+            </a:gs>
+          </a:gsLst>
+          <a:lin ang="16200000" scaled="0"/>
+        </a:gradFill>
+      </a:fillStyleLst>
+      <a:lnStyleLst>
+        <a:ln w="9525" cap="flat" cmpd="sng" algn="ctr">
+          <a:solidFill>
+            <a:schemeClr val="phClr">
+              <a:shade val="95000"/>
+              <a:satMod val="105000"/>
+            </a:schemeClr>
+          </a:solidFill>
+          <a:prstDash val="solid"/>
+        </a:ln>
+        <a:ln w="25400" cap="flat" cmpd="sng" algn="ctr">
+          <a:solidFill>
+            <a:schemeClr val="phClr"/>
+          </a:solidFill>
+          <a:prstDash val="solid"/>
+        </a:ln>
+        <a:ln w="38100" cap="flat" cmpd="sng" algn="ctr">
+          <a:solidFill>
+            <a:schemeClr val="phClr"/>
+          </a:solidFill>
+          <a:prstDash val="solid"/>
+        </a:ln>
+      </a:lnStyleLst>
+      <a:effectStyleLst>
+        <a:effectStyle>
+          <a:effectLst>
+            <a:outerShdw blurRad="40000" dist="20000" dir="5400000" rotWithShape="0">
+              <a:srgbClr val="000000">
+                <a:alpha val="38000"/>
+              </a:srgbClr>
+            </a:outerShdw>
+          </a:effectLst>
+        </a:effectStyle>
+        <a:effectStyle>
+          <a:effectLst>
+            <a:outerShdw blurRad="40000" dist="23000" dir="5400000" rotWithShape="0">
+              <a:srgbClr val="000000">
+                <a:alpha val="35000"/>
+              </a:srgbClr>
+            </a:outerShdw>
+          </a:effectLst>
+        </a:effectStyle>
+        <a:effectStyle>
+          <a:effectLst>
+            <a:outerShdw blurRad="40000" dist="23000" dir="5400000" rotWithShape="0">
+              <a:srgbClr val="000000">
+                <a:alpha val="35000"/>
+              </a:srgbClr>
+            </a:outerShdw>
+          </a:effectLst>
+          <a:scene3d>
+            <a:camera prst="orthographicFront">
+              <a:rot lat="0" lon="0" rev="0"/>
+            </a:camera>
+            <a:lightRig rig="threePt" dir="t">
+              <a:rot lat="0" lon="0" rev="1200000"/>
+            </a:lightRig>
+          </a:scene3d>
+          <a:sp3d>
+            <a:bevelT w="63500" h="25400"/>
+          </a:sp3d>
+        </a:effectStyle>
+      </a:effectStyleLst>
+      <a:bgFillStyleLst>
+        <a:solidFill>
+          <a:schemeClr val="phClr"/>
+        </a:solidFill>
+        <a:gradFill rotWithShape="1">
+          <a:gsLst>
+            <a:gs pos="0">
+              <a:schemeClr val="phClr">
+                <a:tint val="40000"/>
+                <a:satMod val="350000"/>
+              </a:schemeClr>
+            </a:gs>
+            <a:gs pos="40000">
+              <a:schemeClr val="phClr">
+                <a:tint val="45000"/>
+                <a:shade val="99000"/>
+                <a:satMod val="350000"/>
+              </a:schemeClr>
+            </a:gs>
+            <a:gs pos="100000">
+              <a:schemeClr val="phClr">
+                <a:shade val="20000"/>
+                <a:satMod val="255000"/>
+              </a:schemeClr>
+            </a:gs>
+          </a:gsLst>
+          <a:path path="circle">
+            <a:fillToRect l="50000" t="-80000" r="50000" b="180000"/>
+          </a:path>
+        </a:gradFill>
+        <a:gradFill rotWithShape="1">
+          <a:gsLst>
+            <a:gs pos="0">
+              <a:schemeClr val="phClr">
+                <a:tint val="80000"/>
+                <a:satMod val="300000"/>
+              </a:schemeClr>
+            </a:gs>
+            <a:gs pos="100000">
+              <a:schemeClr val="phClr">
+                <a:shade val="30000"/>
+                <a:satMod val="200000"/>
+              </a:schemeClr>
+            </a:gs>
+          </a:gsLst>
+          <a:path path="circle">
+            <a:fillToRect l="50000" t="50000" r="50000" b="50000"/>
+          </a:path>
+        </a:gradFill>
+      </a:bgFillStyleLst>
+    </a:fmtScheme>
+  </a:themeElements>
+  <a:objectDefaults>
+    <a:spDef>
+      <a:spPr/>
+      <a:bodyPr/>
+      <a:lstStyle/>
+      <a:style>
+        <a:lnRef idx="1">
+          <a:schemeClr val="accent1"/>
+        </a:lnRef>
+        <a:fillRef idx="3">
+          <a:schemeClr val="accent1"/>
+        </a:fillRef>
+        <a:effectRef idx="2">
+          <a:schemeClr val="accent1"/>
+        </a:effectRef>
+        <a:fontRef idx="minor">
+          <a:schemeClr val="lt1"/>
+        </a:fontRef>
+      </a:style>
+    </a:spDef>
+    <a:lnDef>
+      <a:spPr/>
+      <a:bodyPr/>
+      <a:lstStyle/>
+      <a:style>
+        <a:lnRef idx="2">
+          <a:schemeClr val="accent1"/>
+        </a:lnRef>
+        <a:fillRef idx="0">
+          <a:schemeClr val="accent1"/>
+        </a:fillRef>
+        <a:effectRef idx="1">
+          <a:schemeClr val="accent1"/>
+        </a:effectRef>
+        <a:fontRef idx="minor">
+          <a:schemeClr val="tx1"/>
+        </a:fontRef>
+      </a:style>
+    </a:lnDef>
+  </a:objectDefaults>
+  <a:extraClrSchemeLst/>
+</a:theme>
 </file>
</xml_diff>